<commit_message>
made minor changes to the Website
</commit_message>
<xml_diff>
--- a/references/Dev Website.pptx
+++ b/references/Dev Website.pptx
@@ -279,7 +279,7 @@
           <a:p>
             <a:fld id="{330FBAAE-51AC-4A7F-9309-D5A186927EDD}" type="datetimeFigureOut">
               <a:rPr lang="en-IN" smtClean="0"/>
-              <a:t>10-01-2026</a:t>
+              <a:t>12-01-2026</a:t>
             </a:fld>
             <a:endParaRPr lang="en-IN"/>
           </a:p>
@@ -479,7 +479,7 @@
           <a:p>
             <a:fld id="{330FBAAE-51AC-4A7F-9309-D5A186927EDD}" type="datetimeFigureOut">
               <a:rPr lang="en-IN" smtClean="0"/>
-              <a:t>10-01-2026</a:t>
+              <a:t>12-01-2026</a:t>
             </a:fld>
             <a:endParaRPr lang="en-IN"/>
           </a:p>
@@ -689,7 +689,7 @@
           <a:p>
             <a:fld id="{330FBAAE-51AC-4A7F-9309-D5A186927EDD}" type="datetimeFigureOut">
               <a:rPr lang="en-IN" smtClean="0"/>
-              <a:t>10-01-2026</a:t>
+              <a:t>12-01-2026</a:t>
             </a:fld>
             <a:endParaRPr lang="en-IN"/>
           </a:p>
@@ -889,7 +889,7 @@
           <a:p>
             <a:fld id="{330FBAAE-51AC-4A7F-9309-D5A186927EDD}" type="datetimeFigureOut">
               <a:rPr lang="en-IN" smtClean="0"/>
-              <a:t>10-01-2026</a:t>
+              <a:t>12-01-2026</a:t>
             </a:fld>
             <a:endParaRPr lang="en-IN"/>
           </a:p>
@@ -1165,7 +1165,7 @@
           <a:p>
             <a:fld id="{330FBAAE-51AC-4A7F-9309-D5A186927EDD}" type="datetimeFigureOut">
               <a:rPr lang="en-IN" smtClean="0"/>
-              <a:t>10-01-2026</a:t>
+              <a:t>12-01-2026</a:t>
             </a:fld>
             <a:endParaRPr lang="en-IN"/>
           </a:p>
@@ -1433,7 +1433,7 @@
           <a:p>
             <a:fld id="{330FBAAE-51AC-4A7F-9309-D5A186927EDD}" type="datetimeFigureOut">
               <a:rPr lang="en-IN" smtClean="0"/>
-              <a:t>10-01-2026</a:t>
+              <a:t>12-01-2026</a:t>
             </a:fld>
             <a:endParaRPr lang="en-IN"/>
           </a:p>
@@ -1848,7 +1848,7 @@
           <a:p>
             <a:fld id="{330FBAAE-51AC-4A7F-9309-D5A186927EDD}" type="datetimeFigureOut">
               <a:rPr lang="en-IN" smtClean="0"/>
-              <a:t>10-01-2026</a:t>
+              <a:t>12-01-2026</a:t>
             </a:fld>
             <a:endParaRPr lang="en-IN"/>
           </a:p>
@@ -1990,7 +1990,7 @@
           <a:p>
             <a:fld id="{330FBAAE-51AC-4A7F-9309-D5A186927EDD}" type="datetimeFigureOut">
               <a:rPr lang="en-IN" smtClean="0"/>
-              <a:t>10-01-2026</a:t>
+              <a:t>12-01-2026</a:t>
             </a:fld>
             <a:endParaRPr lang="en-IN"/>
           </a:p>
@@ -2103,7 +2103,7 @@
           <a:p>
             <a:fld id="{330FBAAE-51AC-4A7F-9309-D5A186927EDD}" type="datetimeFigureOut">
               <a:rPr lang="en-IN" smtClean="0"/>
-              <a:t>10-01-2026</a:t>
+              <a:t>12-01-2026</a:t>
             </a:fld>
             <a:endParaRPr lang="en-IN"/>
           </a:p>
@@ -2416,7 +2416,7 @@
           <a:p>
             <a:fld id="{330FBAAE-51AC-4A7F-9309-D5A186927EDD}" type="datetimeFigureOut">
               <a:rPr lang="en-IN" smtClean="0"/>
-              <a:t>10-01-2026</a:t>
+              <a:t>12-01-2026</a:t>
             </a:fld>
             <a:endParaRPr lang="en-IN"/>
           </a:p>
@@ -2705,7 +2705,7 @@
           <a:p>
             <a:fld id="{330FBAAE-51AC-4A7F-9309-D5A186927EDD}" type="datetimeFigureOut">
               <a:rPr lang="en-IN" smtClean="0"/>
-              <a:t>10-01-2026</a:t>
+              <a:t>12-01-2026</a:t>
             </a:fld>
             <a:endParaRPr lang="en-IN"/>
           </a:p>
@@ -2948,7 +2948,7 @@
           <a:p>
             <a:fld id="{330FBAAE-51AC-4A7F-9309-D5A186927EDD}" type="datetimeFigureOut">
               <a:rPr lang="en-IN" smtClean="0"/>
-              <a:t>10-01-2026</a:t>
+              <a:t>12-01-2026</a:t>
             </a:fld>
             <a:endParaRPr lang="en-IN"/>
           </a:p>
@@ -7281,7 +7281,7 @@
         </p:blipFill>
         <p:spPr>
           <a:xfrm>
-            <a:off x="1" y="0"/>
+            <a:off x="0" y="0"/>
             <a:ext cx="9542352" cy="4360214"/>
           </a:xfrm>
           <a:prstGeom prst="rect">
@@ -8048,10 +8048,10 @@
       </p:pic>
       <p:pic>
         <p:nvPicPr>
-          <p:cNvPr id="19" name="Graphic 18" descr="Clock with solid fill">
-            <a:extLst>
-              <a:ext uri="{FF2B5EF4-FFF2-40B4-BE49-F238E27FC236}">
-                <a16:creationId xmlns:a16="http://schemas.microsoft.com/office/drawing/2014/main" id="{7BC43882-CED7-5AAC-3A18-73E90D817071}"/>
+          <p:cNvPr id="10" name="Graphic 9" descr="Checkmark with solid fill">
+            <a:extLst>
+              <a:ext uri="{FF2B5EF4-FFF2-40B4-BE49-F238E27FC236}">
+                <a16:creationId xmlns:a16="http://schemas.microsoft.com/office/drawing/2014/main" id="{C3447745-C4CA-62A2-CEB4-07877265283E}"/>
               </a:ext>
             </a:extLst>
           </p:cNvPr>
@@ -8061,10 +8061,10 @@
           <p:nvPr/>
         </p:nvPicPr>
         <p:blipFill>
-          <a:blip r:embed="rId5">
+          <a:blip r:embed="rId3">
             <a:extLst>
               <a:ext uri="{96DAC541-7B7A-43D3-8B79-37D633B846F1}">
-                <asvg:svgBlip xmlns:asvg="http://schemas.microsoft.com/office/drawing/2016/SVG/main" r:embed="rId6"/>
+                <asvg:svgBlip xmlns:asvg="http://schemas.microsoft.com/office/drawing/2016/SVG/main" r:embed="rId4"/>
               </a:ext>
             </a:extLst>
           </a:blip>
@@ -8074,8 +8074,8 @@
         </p:blipFill>
         <p:spPr>
           <a:xfrm>
-            <a:off x="452213" y="1327355"/>
-            <a:ext cx="920583" cy="920583"/>
+            <a:off x="778772" y="1810292"/>
+            <a:ext cx="779400" cy="779400"/>
           </a:xfrm>
           <a:prstGeom prst="rect">
             <a:avLst/>

</xml_diff>